<commit_message>
data(discovery): corpus coding to 83% (1066/1284), findings stable
Resumed after the key rotation; Google's daily budget ran out at 1066. The
extra 236 documents over the 65% run did not move the conclusion: operational
themes still dominate raw share of voice, the habit-themed core themes still
lead strategic priority, and the trial/risk bridge is still tiny (41 docs, 40
of them in context themes). Stability across a third more data is worth stating.

917 documents carry a theme, 149 fit none, core is 33 documents. /discovery,
sensitivity and the deck regenerated from the fuller corpus.

Remaining 218 documents and the second-pass reliability check both need Gemini
and wait for the next quota reset.

Co-Authored-By: Claude Opus 4.8 <noreply@anthropic.com>
</commit_message>
<xml_diff>
--- a/deck/Blinkit-Moments-Fellowship.pptx
+++ b/deck/Blinkit-Moments-Fellowship.pptx
@@ -5686,7 +5686,7 @@
                 <a:ea typeface="Calibri" pitchFamily="34" charset="-122"/>
                 <a:cs typeface="Calibri" pitchFamily="34" charset="-120"/>
               </a:rPr>
-              <a:t>Google Play, App Store and Reddit, scraped and de-duplicated. 799 coded by an LLM against a codebook induced from the data itself.</a:t>
+              <a:t>Google Play, App Store and Reddit, scraped and de-duplicated. 917 coded by an LLM against a codebook induced from the data itself.</a:t>
             </a:r>
             <a:endParaRPr lang="en-US" sz="1250" dirty="0"/>
           </a:p>
@@ -6610,7 +6610,7 @@
                 <a:ea typeface="Calibri" pitchFamily="34" charset="-122"/>
                 <a:cs typeface="Calibri" pitchFamily="34" charset="-120"/>
               </a:rPr>
-              <a:t>The habitual-purchasing theme is n=8</a:t>
+              <a:t>The habitual-purchasing theme is n=11</a:t>
             </a:r>
             <a:endParaRPr lang="en-US" sz="1300" dirty="0"/>
           </a:p>
@@ -6670,7 +6670,7 @@
                 <a:ea typeface="Calibri" pitchFamily="34" charset="-122"/>
                 <a:cs typeface="Calibri" pitchFamily="34" charset="-120"/>
               </a:rPr>
-              <a:t>Actual: 40 documents. Claim withdrawn.</a:t>
+              <a:t>Actual: 41 documents. Claim withdrawn.</a:t>
             </a:r>
             <a:endParaRPr lang="en-US" sz="1200" dirty="0"/>
           </a:p>
@@ -9556,7 +9556,7 @@
                           <a:ea typeface="Calibri" pitchFamily="34" charset="-122"/>
                           <a:cs typeface="Calibri" pitchFamily="34" charset="-120"/>
                         </a:rPr>
-                        <a:t>40 docs (5%)</a:t>
+                        <a:t>41 docs (5%)</a:t>
                       </a:r>
                       <a:endParaRPr lang="en-US" sz="1200" dirty="0">
                         <a:latin typeface="Calibri" charset="0"/>

</xml_diff>

<commit_message>
data(discovery): corpus fully coded — 1284/1284
Coded the last 218 documents. Full corpus: 1011 accepted, 273 fit no theme
(21% — the rejection counter is doing substantial, honest work), all 13 themes
now clear the two-source rule.

Findings held steady from the 83% partial to the 100% corpus, which is the
point of finishing it — the conclusions were not an artefact of where coding
happened to stop. The trial/risk bridge is 48 docs, 47 of them in context
themes: the corpus still does not support the occasion thesis, exactly as at
799 and 1066. Regenerated insights, sensitivity and deck against the complete
data so every surface reads 1284.

Hold-out κ unchanged (0.566, cross-model) — the 60 sampled docs were coded in
the first pass and coding is idempotent.

Co-Authored-By: Claude Opus 4.8 <noreply@anthropic.com>
</commit_message>
<xml_diff>
--- a/deck/Blinkit-Moments-Fellowship.pptx
+++ b/deck/Blinkit-Moments-Fellowship.pptx
@@ -5686,7 +5686,7 @@
                 <a:ea typeface="Calibri" pitchFamily="34" charset="-122"/>
                 <a:cs typeface="Calibri" pitchFamily="34" charset="-120"/>
               </a:rPr>
-              <a:t>Google Play, App Store and Reddit, scraped and de-duplicated. 917 coded by an LLM against a codebook induced from the data itself.</a:t>
+              <a:t>Google Play, App Store and Reddit, scraped and de-duplicated. 1011 coded by an LLM against a codebook induced from the data itself.</a:t>
             </a:r>
             <a:endParaRPr lang="en-US" sz="1250" dirty="0"/>
           </a:p>
@@ -6631,7 +6631,7 @@
                 <a:ea typeface="Calibri" pitchFamily="34" charset="-122"/>
                 <a:cs typeface="Calibri" pitchFamily="34" charset="-120"/>
               </a:rPr>
-              <a:t>The habitual-purchasing theme is n=11</a:t>
+              <a:t>The habitual-purchasing theme is n=15</a:t>
             </a:r>
             <a:endParaRPr lang="en-US" sz="1300" dirty="0"/>
           </a:p>
@@ -6691,7 +6691,7 @@
                 <a:ea typeface="Calibri" pitchFamily="34" charset="-122"/>
                 <a:cs typeface="Calibri" pitchFamily="34" charset="-120"/>
               </a:rPr>
-              <a:t>Actual: 41 documents. Claim withdrawn.</a:t>
+              <a:t>Actual: 48 documents. Claim withdrawn.</a:t>
             </a:r>
             <a:endParaRPr lang="en-US" sz="1200" dirty="0"/>
           </a:p>
@@ -9577,7 +9577,7 @@
                           <a:ea typeface="Calibri" pitchFamily="34" charset="-122"/>
                           <a:cs typeface="Calibri" pitchFamily="34" charset="-120"/>
                         </a:rPr>
-                        <a:t>41 docs (5%)</a:t>
+                        <a:t>48 docs (5%)</a:t>
                       </a:r>
                       <a:endParaRPr lang="en-US" sz="1200" dirty="0">
                         <a:latin typeface="Calibri" charset="0"/>

</xml_diff>

<commit_message>
deck: survey out-of-basket triggers as a pie chart
Slide 6's bar becomes a pie. Q11 is single-select so the shares sum to 100% —
a valid whole to pie. (The barrier question stays a bar: it is multi-select and
sums to 130%, so a pie of it would misrepresent the data.)

Occasion slices in greens, ran-out/deal grey, in-app recommendation rust as the
contrast — same semantics as the bar it replaces, so festival+hosting+season
still read as the 46% the callout claims. Labels show % per slice, legend on
the right. Validated and visually checked.

Co-Authored-By: Claude Opus 4.8 <noreply@anthropic.com>
</commit_message>
<xml_diff>
--- a/deck/Blinkit-Moments-Fellowship.pptx
+++ b/deck/Blinkit-Moments-Fellowship.pptx
@@ -408,10 +408,8 @@
     <c:autoTitleDeleted val="1"/>
     <c:plotArea>
       <c:layout/>
-      <c:barChart>
-        <c:barDir val="bar"/>
-        <c:grouping val="clustered"/>
-        <c:varyColors val="0"/>
+      <c:pieChart>
+        <c:varyColors val="1"/>
         <c:ser>
           <c:idx val="0"/>
           <c:order val="0"/>
@@ -428,38 +426,19 @@
           </c:tx>
           <c:spPr>
             <a:solidFill>
-              <a:srgbClr val="0C831F"/>
+              <a:schemeClr val="accent1"/>
             </a:solidFill>
+            <a:ln w="9525" cap="flat">
+              <a:solidFill>
+                <a:srgbClr val="F9F9F9"/>
+              </a:solidFill>
+              <a:prstDash val="solid"/>
+              <a:round/>
+            </a:ln>
             <a:effectLst/>
           </c:spPr>
-          <c:invertIfNegative val="0"/>
-          <c:dLbls>
-            <c:numFmt formatCode="0&quot;%&quot;" sourceLinked="0"/>
-            <c:txPr>
-              <a:bodyPr/>
-              <a:lstStyle/>
-              <a:p>
-                <a:pPr>
-                  <a:defRPr b="0" i="0" strike="noStrike" sz="1200" u="none">
-                    <a:solidFill>
-                      <a:srgbClr val="0F2417"/>
-                    </a:solidFill>
-                    <a:latin typeface="Calibri"/>
-                  </a:defRPr>
-                </a:pPr>
-              </a:p>
-            </c:txPr>
-            <c:showLegendKey val="0"/>
-            <c:showVal val="1"/>
-            <c:showCatName val="0"/>
-            <c:showSerName val="0"/>
-            <c:showPercent val="0"/>
-            <c:showBubbleSize val="0"/>
-            <c:showLeaderLines val="0"/>
-          </c:dLbls>
           <c:dPt>
             <c:idx val="0"/>
-            <c:invertIfNegative val="0"/>
             <c:bubble3D val="0"/>
             <c:spPr>
               <a:solidFill>
@@ -470,7 +449,6 @@
           </c:dPt>
           <c:dPt>
             <c:idx val="1"/>
-            <c:invertIfNegative val="0"/>
             <c:bubble3D val="0"/>
             <c:spPr>
               <a:solidFill>
@@ -481,7 +459,6 @@
           </c:dPt>
           <c:dPt>
             <c:idx val="2"/>
-            <c:invertIfNegative val="0"/>
             <c:bubble3D val="0"/>
             <c:spPr>
               <a:solidFill>
@@ -492,18 +469,16 @@
           </c:dPt>
           <c:dPt>
             <c:idx val="3"/>
-            <c:invertIfNegative val="0"/>
             <c:bubble3D val="0"/>
             <c:spPr>
               <a:solidFill>
-                <a:srgbClr val="0C831F"/>
+                <a:srgbClr val="0A6E19"/>
               </a:solidFill>
               <a:effectLst/>
             </c:spPr>
           </c:dPt>
           <c:dPt>
             <c:idx val="4"/>
-            <c:invertIfNegative val="0"/>
             <c:bubble3D val="0"/>
             <c:spPr>
               <a:solidFill>
@@ -514,182 +489,250 @@
           </c:dPt>
           <c:dPt>
             <c:idx val="5"/>
-            <c:invertIfNegative val="0"/>
             <c:bubble3D val="0"/>
             <c:spPr>
               <a:solidFill>
-                <a:srgbClr val="0C831F"/>
+                <a:srgbClr val="3A7D44"/>
               </a:solidFill>
               <a:effectLst/>
             </c:spPr>
           </c:dPt>
+          <c:dLbls>
+            <c:dLbl>
+              <c:idx val="0"/>
+              <c:numFmt formatCode="0&quot;%&quot;" sourceLinked="0"/>
+              <c:spPr/>
+              <c:txPr>
+                <a:bodyPr/>
+                <a:lstStyle/>
+                <a:p>
+                  <a:pPr>
+                    <a:defRPr sz="1100" b="0" i="0" u="none" strike="noStrike">
+                      <a:solidFill>
+                        <a:srgbClr val="FFFFFF"/>
+                      </a:solidFill>
+                      <a:latin typeface="Calibri"/>
+                    </a:defRPr>
+                  </a:pPr>
+                </a:p>
+              </c:txPr>
+              <c:dLblPos val="bestFit"/>
+              <c:showLegendKey val="0"/>
+              <c:showVal val="1"/>
+              <c:showCatName val="0"/>
+              <c:showSerName val="0"/>
+              <c:showPercent val="0"/>
+              <c:showBubbleSize val="0"/>
+            </c:dLbl>
+            <c:dLbl>
+              <c:idx val="1"/>
+              <c:numFmt formatCode="0&quot;%&quot;" sourceLinked="0"/>
+              <c:spPr/>
+              <c:txPr>
+                <a:bodyPr/>
+                <a:lstStyle/>
+                <a:p>
+                  <a:pPr>
+                    <a:defRPr sz="1100" b="0" i="0" u="none" strike="noStrike">
+                      <a:solidFill>
+                        <a:srgbClr val="FFFFFF"/>
+                      </a:solidFill>
+                      <a:latin typeface="Calibri"/>
+                    </a:defRPr>
+                  </a:pPr>
+                </a:p>
+              </c:txPr>
+              <c:dLblPos val="bestFit"/>
+              <c:showLegendKey val="0"/>
+              <c:showVal val="1"/>
+              <c:showCatName val="0"/>
+              <c:showSerName val="0"/>
+              <c:showPercent val="0"/>
+              <c:showBubbleSize val="0"/>
+            </c:dLbl>
+            <c:dLbl>
+              <c:idx val="2"/>
+              <c:numFmt formatCode="0&quot;%&quot;" sourceLinked="0"/>
+              <c:spPr/>
+              <c:txPr>
+                <a:bodyPr/>
+                <a:lstStyle/>
+                <a:p>
+                  <a:pPr>
+                    <a:defRPr sz="1100" b="0" i="0" u="none" strike="noStrike">
+                      <a:solidFill>
+                        <a:srgbClr val="FFFFFF"/>
+                      </a:solidFill>
+                      <a:latin typeface="Calibri"/>
+                    </a:defRPr>
+                  </a:pPr>
+                </a:p>
+              </c:txPr>
+              <c:dLblPos val="bestFit"/>
+              <c:showLegendKey val="0"/>
+              <c:showVal val="1"/>
+              <c:showCatName val="0"/>
+              <c:showSerName val="0"/>
+              <c:showPercent val="0"/>
+              <c:showBubbleSize val="0"/>
+            </c:dLbl>
+            <c:dLbl>
+              <c:idx val="3"/>
+              <c:numFmt formatCode="0&quot;%&quot;" sourceLinked="0"/>
+              <c:spPr/>
+              <c:txPr>
+                <a:bodyPr/>
+                <a:lstStyle/>
+                <a:p>
+                  <a:pPr>
+                    <a:defRPr sz="1100" b="0" i="0" u="none" strike="noStrike">
+                      <a:solidFill>
+                        <a:srgbClr val="FFFFFF"/>
+                      </a:solidFill>
+                      <a:latin typeface="Calibri"/>
+                    </a:defRPr>
+                  </a:pPr>
+                </a:p>
+              </c:txPr>
+              <c:dLblPos val="bestFit"/>
+              <c:showLegendKey val="0"/>
+              <c:showVal val="1"/>
+              <c:showCatName val="0"/>
+              <c:showSerName val="0"/>
+              <c:showPercent val="0"/>
+              <c:showBubbleSize val="0"/>
+            </c:dLbl>
+            <c:dLbl>
+              <c:idx val="4"/>
+              <c:numFmt formatCode="0&quot;%&quot;" sourceLinked="0"/>
+              <c:spPr/>
+              <c:txPr>
+                <a:bodyPr/>
+                <a:lstStyle/>
+                <a:p>
+                  <a:pPr>
+                    <a:defRPr sz="1100" b="0" i="0" u="none" strike="noStrike">
+                      <a:solidFill>
+                        <a:srgbClr val="FFFFFF"/>
+                      </a:solidFill>
+                      <a:latin typeface="Calibri"/>
+                    </a:defRPr>
+                  </a:pPr>
+                </a:p>
+              </c:txPr>
+              <c:dLblPos val="bestFit"/>
+              <c:showLegendKey val="0"/>
+              <c:showVal val="1"/>
+              <c:showCatName val="0"/>
+              <c:showSerName val="0"/>
+              <c:showPercent val="0"/>
+              <c:showBubbleSize val="0"/>
+            </c:dLbl>
+            <c:dLbl>
+              <c:idx val="5"/>
+              <c:numFmt formatCode="0&quot;%&quot;" sourceLinked="0"/>
+              <c:spPr/>
+              <c:txPr>
+                <a:bodyPr/>
+                <a:lstStyle/>
+                <a:p>
+                  <a:pPr>
+                    <a:defRPr sz="1100" b="0" i="0" u="none" strike="noStrike">
+                      <a:solidFill>
+                        <a:srgbClr val="FFFFFF"/>
+                      </a:solidFill>
+                      <a:latin typeface="Calibri"/>
+                    </a:defRPr>
+                  </a:pPr>
+                </a:p>
+              </c:txPr>
+              <c:dLblPos val="bestFit"/>
+              <c:showLegendKey val="0"/>
+              <c:showVal val="1"/>
+              <c:showCatName val="0"/>
+              <c:showSerName val="0"/>
+              <c:showPercent val="0"/>
+              <c:showBubbleSize val="0"/>
+            </c:dLbl>
+            <c:numFmt formatCode="0&quot;%&quot;" sourceLinked="0"/>
+            <c:txPr>
+              <a:bodyPr/>
+              <a:lstStyle/>
+              <a:p>
+                <a:pPr>
+                  <a:defRPr sz="1800" b="0" i="0" u="none" strike="noStrike">
+                    <a:solidFill>
+                      <a:srgbClr val="000000"/>
+                    </a:solidFill>
+                    <a:latin typeface="Arial"/>
+                  </a:defRPr>
+                </a:pPr>
+              </a:p>
+            </c:txPr>
+            <c:dLblPos val="ctr"/>
+            <c:showLegendKey val="0"/>
+            <c:showVal val="0"/>
+            <c:showCatName val="1"/>
+            <c:showSerName val="0"/>
+            <c:showPercent val="1"/>
+            <c:showBubbleSize val="0"/>
+            <c:showLeaderLines val="0"/>
+          </c:dLbls>
           <c:cat>
-            <c:multiLvlStrRef>
+            <c:strRef>
               <c:f>Sheet1!$A$2:$A$7</c:f>
-              <c:multiLvlStrCache>
+              <c:strCache>
                 <c:ptCount val="6"/>
-                <c:lvl>
-                  <c:pt idx="0">
-                    <c:v>A festival or celebration</c:v>
-                  </c:pt>
-                  <c:pt idx="1">
-                    <c:v>Ran out of something at home</c:v>
-                  </c:pt>
-                  <c:pt idx="2">
-                    <c:v>Saw a deal or offer</c:v>
-                  </c:pt>
-                  <c:pt idx="3">
-                    <c:v>Hosting / guests coming over</c:v>
-                  </c:pt>
-                  <c:pt idx="4">
-                    <c:v>A recommendation</c:v>
-                  </c:pt>
-                  <c:pt idx="5">
-                    <c:v>Season or weather</c:v>
-                  </c:pt>
-                </c:lvl>
-              </c:multiLvlStrCache>
-            </c:multiLvlStrRef>
+                <c:pt idx="0">
+                  <c:v>A festival or celebration</c:v>
+                </c:pt>
+                <c:pt idx="1">
+                  <c:v>Ran out of something at home</c:v>
+                </c:pt>
+                <c:pt idx="2">
+                  <c:v>Saw a deal or offer</c:v>
+                </c:pt>
+                <c:pt idx="3">
+                  <c:v>Hosting / guests coming over</c:v>
+                </c:pt>
+                <c:pt idx="4">
+                  <c:v>A recommendation</c:v>
+                </c:pt>
+                <c:pt idx="5">
+                  <c:v>Season or weather</c:v>
+                </c:pt>
+              </c:strCache>
+            </c:strRef>
           </c:cat>
           <c:val>
             <c:numRef>
               <c:f>Sheet1!$B$2:$B$7</c:f>
               <c:numCache>
-                <c:formatCode>General</c:formatCode>
                 <c:ptCount val="6"/>
                 <c:pt idx="0">
-                  <c:v>30.8</c:v>
+                  <c:v>31</c:v>
                 </c:pt>
                 <c:pt idx="1">
-                  <c:v>26.900000000000002</c:v>
+                  <c:v>27</c:v>
                 </c:pt>
                 <c:pt idx="2">
-                  <c:v>19.2</c:v>
+                  <c:v>19</c:v>
                 </c:pt>
                 <c:pt idx="3">
-                  <c:v>11.5</c:v>
+                  <c:v>12</c:v>
                 </c:pt>
                 <c:pt idx="4">
-                  <c:v>7.7</c:v>
+                  <c:v>8</c:v>
                 </c:pt>
                 <c:pt idx="5">
-                  <c:v>3.8</c:v>
+                  <c:v>4</c:v>
                 </c:pt>
               </c:numCache>
             </c:numRef>
           </c:val>
         </c:ser>
-        <c:dLbls>
-          <c:numFmt formatCode="0&quot;%&quot;" sourceLinked="0"/>
-          <c:txPr>
-            <a:bodyPr/>
-            <a:lstStyle/>
-            <a:p>
-              <a:pPr>
-                <a:defRPr b="0" i="0" strike="noStrike" sz="1200" u="none">
-                  <a:solidFill>
-                    <a:srgbClr val="0F2417"/>
-                  </a:solidFill>
-                  <a:latin typeface="Calibri"/>
-                </a:defRPr>
-              </a:pPr>
-            </a:p>
-          </c:txPr>
-          <c:showLegendKey val="0"/>
-          <c:showVal val="1"/>
-          <c:showCatName val="0"/>
-          <c:showSerName val="0"/>
-          <c:showPercent val="0"/>
-          <c:showBubbleSize val="0"/>
-          <c:showLeaderLines val="0"/>
-        </c:dLbls>
-        <c:gapWidth val="45"/>
-        <c:overlap val="0"/>
-        <c:axId val="2094734554"/>
-        <c:axId val="2094734552"/>
-        <c:axId val="2094734556"/>
-      </c:barChart>
-      <c:catAx>
-        <c:axId val="2094734554"/>
-        <c:scaling>
-          <c:orientation val="minMax"/>
-        </c:scaling>
-        <c:delete val="0"/>
-        <c:axPos val="l"/>
-        <c:numFmt formatCode="General" sourceLinked="1"/>
-        <c:majorTickMark val="out"/>
-        <c:minorTickMark val="none"/>
-        <c:tickLblPos val="nextTo"/>
-        <c:spPr>
-          <a:ln w="12700" cap="flat">
-            <a:solidFill>
-              <a:srgbClr val="888888"/>
-            </a:solidFill>
-            <a:prstDash val="solid"/>
-            <a:round/>
-          </a:ln>
-        </c:spPr>
-        <c:txPr>
-          <a:bodyPr/>
-          <a:lstStyle/>
-          <a:p>
-            <a:pPr>
-              <a:defRPr sz="1100" b="0" i="0" u="none" strike="noStrike">
-                <a:solidFill>
-                  <a:srgbClr val="0F2417"/>
-                </a:solidFill>
-                <a:latin typeface="Calibri"/>
-              </a:defRPr>
-            </a:pPr>
-            <a:endParaRPr lang="en-US"/>
-          </a:p>
-        </c:txPr>
-        <c:crossAx val="2094734552"/>
-        <c:crosses val="autoZero"/>
-        <c:auto val="1"/>
-        <c:lblAlgn val="ctr"/>
-        <c:noMultiLvlLbl val="1"/>
-      </c:catAx>
-      <c:valAx>
-        <c:axId val="2094734552"/>
-        <c:scaling>
-          <c:orientation val="minMax"/>
-          <c:max val="40"/>
-        </c:scaling>
-        <c:delete val="1"/>
-        <c:axPos val="b"/>
-        <c:numFmt formatCode="General" sourceLinked="0"/>
-        <c:majorTickMark val="out"/>
-        <c:minorTickMark val="none"/>
-        <c:tickLblPos val="low"/>
-        <c:spPr>
-          <a:ln w="12700" cap="flat">
-            <a:solidFill>
-              <a:srgbClr val="888888"/>
-            </a:solidFill>
-            <a:prstDash val="solid"/>
-            <a:round/>
-          </a:ln>
-        </c:spPr>
-        <c:txPr>
-          <a:bodyPr/>
-          <a:lstStyle/>
-          <a:p>
-            <a:pPr>
-              <a:defRPr sz="1200" b="0" i="0" u="none" strike="noStrike">
-                <a:solidFill>
-                  <a:srgbClr val="000000"/>
-                </a:solidFill>
-                <a:latin typeface="Arial"/>
-              </a:defRPr>
-            </a:pPr>
-            <a:endParaRPr lang="en-US"/>
-          </a:p>
-        </c:txPr>
-        <c:crossAx val="2094734554"/>
-        <c:crosses val="autoZero"/>
-        <c:crossBetween val="between"/>
-      </c:valAx>
+        <c:firstSliceAng val="0"/>
+      </c:pieChart>
       <c:spPr>
         <a:noFill/>
         <a:ln>
@@ -698,6 +741,26 @@
         <a:effectLst/>
       </c:spPr>
     </c:plotArea>
+    <c:legend>
+      <c:legendPos val="r"/>
+      <c:overlay val="0"/>
+      <c:txPr>
+        <a:bodyPr/>
+        <a:lstStyle/>
+        <a:p>
+          <a:pPr>
+            <a:defRPr sz="1000">
+              <a:solidFill>
+                <a:srgbClr val="0F2417"/>
+              </a:solidFill>
+              <a:latin typeface="Calibri"/>
+              <a:cs typeface="Calibri"/>
+            </a:defRPr>
+          </a:pPr>
+          <a:endParaRPr lang="en-US"/>
+        </a:p>
+      </c:txPr>
+    </c:legend>
     <c:plotVisOnly val="1"/>
     <c:dispBlanksAs val="span"/>
   </c:chart>
@@ -7265,8 +7328,8 @@
           <p:nvPr/>
         </p:nvGraphicFramePr>
         <p:xfrm>
-          <a:off x="640080" y="1645920"/>
-          <a:ext cx="6675120" cy="3931920"/>
+          <a:off x="640080" y="1600200"/>
+          <a:ext cx="6400800" cy="4114800"/>
         </p:xfrm>
         <a:graphic xmlns:a="http://schemas.openxmlformats.org/drawingml/2006/main">
           <a:graphicData uri="http://schemas.openxmlformats.org/drawingml/2006/chart">

</xml_diff>